<commit_message>
Midterm report: add 3-language plan (ID/EN/KO) to planned improvements
Co-Authored-By: Claude Opus 5.5 <noreply@anthropic.com>
Claude-Session: https://claude.ai/code/session_011FKYm5BVbSYFMSWBzSeGDt
</commit_message>
<xml_diff>
--- a/docs/PortofoliYou_Midterm_Report.pptx
+++ b/docs/PortofoliYou_Midterm_Report.pptx
@@ -122,12 +122,12 @@
   <p:extLst>
     <p:ext uri="{521415D9-36F7-43E2-AB2F-B90AF26B5E84}">
       <p14:sectionLst xmlns:p14="http://schemas.microsoft.com/office/powerpoint/2010/main">
-        <p14:section name="Introduction" id="{645dd44a-e915-8c77-34b6-b3cd89904d14}">
+        <p14:section name="Introduction" id="{a124eb84-4cf0-598d-86d2-03e62fbe4f02}">
           <p14:sldIdLst>
             <p14:sldId id="256"/>
           </p14:sldIdLst>
         </p14:section>
-        <p14:section name="Project Overview" id="{ca196d38-47d7-c767-420c-80784deab1ce}">
+        <p14:section name="Project Overview" id="{5a4936ab-6f6d-5ccb-2b6b-259e207d3791}">
           <p14:sldIdLst>
             <p14:sldId id="257"/>
             <p14:sldId id="258"/>
@@ -138,26 +138,26 @@
             <p14:sldId id="263"/>
           </p14:sldIdLst>
         </p14:section>
-        <p14:section name="Generative AI Prompts" id="{b6d38045-4316-17d5-718d-5dd19a2e70a9}">
+        <p14:section name="Generative AI Prompts" id="{cbe9e8fc-07ff-53c4-c25c-1a4c65539913}">
           <p14:sldIdLst>
             <p14:sldId id="264"/>
             <p14:sldId id="265"/>
             <p14:sldId id="266"/>
           </p14:sldIdLst>
         </p14:section>
-        <p14:section name="Current Status" id="{aa584f84-766d-b126-1e31-af8be989276e}">
+        <p14:section name="Current Status" id="{a7bf2bfa-058e-d545-14f1-51c7bdd21d72}">
           <p14:sldIdLst>
             <p14:sldId id="267"/>
           </p14:sldIdLst>
         </p14:section>
-        <p14:section name="Future Plans" id="{1907e017-7424-9a7a-c189-9f10e1057628}">
+        <p14:section name="Future Plans" id="{5c616ce7-21ca-718c-b3b4-41b2abedca96}">
           <p14:sldIdLst>
             <p14:sldId id="268"/>
             <p14:sldId id="269"/>
             <p14:sldId id="270"/>
           </p14:sldIdLst>
         </p14:section>
-        <p14:section name="Closing" id="{76a195b1-4d65-9fdd-790e-8221370a3ac7}">
+        <p14:section name="Closing" id="{3b9c4b50-2f8a-6bcc-6113-4ad903d2aac4}">
           <p14:sldIdLst>
             <p14:sldId id="271"/>
           </p14:sldIdLst>
@@ -1006,7 +1006,7 @@
           <a:p>
             <a:r>
               <a:rPr lang="en-US" dirty="0"/>
-              <a:t>After the content is in, I plan these improvements: proper link previews for when I share the site, faster loading, an accessibility check, a gallery viewer, and better admin tools. Multi-select categories is an open question that I'll decide after user testing. I'm also keeping a clear out-of-scope list so the project stays finishable in eleven weeks.</a:t>
+              <a:t>After the content is in, I plan these improvements: proper link previews for when I share the site, faster loading, an accessibility check, and better admin tools. A new addition is three languages: I'm Indonesian and live in Korea, so my visitors may be Indonesian, Korean or international. I plan a language switcher for Indonesian, English and Korean. Multi-language was originally out of scope, so this is a deliberate scope change, planned after the real content is in. Multi-select categories is an open question that I'll decide after user testing. I'm also keeping a clear out-of-scope list so the project stays finishable in eleven weeks.</a:t>
             </a:r>
             <a:endParaRPr lang="en-US" dirty="0"/>
           </a:p>
@@ -7877,7 +7877,7 @@
                   <a:schemeClr val="tx1"/>
                 </a:solidFill>
               </a:rPr>
-              <a:t>Gallery viewer</a:t>
+              <a:t>3 languages: ID · EN · KO</a:t>
             </a:r>
             <a:endParaRPr lang="en-US" sz="1300" dirty="0"/>
           </a:p>
@@ -7913,7 +7913,7 @@
                   <a:schemeClr val="tx2"/>
                 </a:solidFill>
               </a:rPr>
-              <a:t>Open stills in a full-screen viewer.</a:t>
+              <a:t>Language switcher for Indonesian, English and Korean visitors.</a:t>
             </a:r>
             <a:endParaRPr lang="en-US" sz="1100" dirty="0"/>
           </a:p>
@@ -8311,7 +8311,7 @@
                   <a:schemeClr val="tx2"/>
                 </a:solidFill>
               </a:rPr>
-              <a:t>AI recommendations, visitor accounts, payment, chat, visitor tracking/analytics, file uploads, multi-language.</a:t>
+              <a:t>AI recommendations, visitor accounts, payment, chat, visitor tracking/analytics, file uploads.</a:t>
             </a:r>
             <a:endParaRPr lang="en-US" sz="1200" dirty="0"/>
           </a:p>

</xml_diff>